<commit_message>
fix: replace unsourced 5-8% SOC RMSE with actual fleet numbers in comparison slides; foreground R²=0.9217 in architecture doc
</commit_message>
<xml_diff>
--- a/scripts/pybamm_comparison_slides.pptx
+++ b/scripts/pybamm_comparison_slides.pptx
@@ -4723,7 +4723,7 @@
                   <a:srgbClr val="1A2E5A"/>
                 </a:solidFill>
               </a:rPr>
-              <a:t>③ The PCHIP fleet calibration is what makes the EKF competitive</a:t>
+              <a:t>③ Fleet SOC accuracy is OCV-model-limited (sourced numbers)</a:t>
             </a:r>
           </a:p>
           <a:p>
@@ -4738,7 +4738,7 @@
                   <a:srgbClr val="222222"/>
                 </a:solidFill>
               </a:rPr>
-              <a:t>Validated SOC RMSE is 5–8% after fleet PCHIP calibration (12-bin δV(SOC) correction on 10% held-out cal split).  This comparison shows WHY that calibration matters: the dominant single-trip error is OCV model mismatch — exactly what PCHIP fixes.  Without it the EKF is no better than Coulomb counting; with it, it is.</a:t>
+              <a:t>Mode B (free-running EKF, +20% init offset, PCHIP cal, held-out 90%): Deng BAIC 11.9% · BMW i3 20.8% · VED 25.5% SOC RMSE.  Spread reflects OCV-model chemistry mismatch, not filter instability — the EKF converges and stays bounded; accuracy is gated by OCV table quality.</a:t>
             </a:r>
           </a:p>
           <a:p>
@@ -5007,7 +5007,7 @@
                   <a:srgbClr val="1A2E5A"/>
                 </a:solidFill>
               </a:rPr>
-              <a:t>  SOC RMSE (fleet, w/ PCHIP cal):</a:t>
+              <a:t>  Voltage MAE (Quartz WLTP, 36 cells):</a:t>
             </a:r>
           </a:p>
           <a:p>
@@ -5022,7 +5022,7 @@
                   <a:srgbClr val="1E7A3E"/>
                 </a:solidFill>
               </a:rPr>
-              <a:t>    5–8%</a:t>
+              <a:t>    18.6 mV  ✓  &lt; 20 mV target</a:t>
             </a:r>
           </a:p>
           <a:p>
@@ -5037,7 +5037,7 @@
                   <a:srgbClr val="1A2E5A"/>
                 </a:solidFill>
               </a:rPr>
-              <a:t>  Voltage MAE (Quartz WLTP 36-cell):</a:t>
+              <a:t>  Fleet SOC RMSE (Deng / BMW / VED):</a:t>
             </a:r>
           </a:p>
           <a:p>
@@ -5052,7 +5052,7 @@
                   <a:srgbClr val="1E7A3E"/>
                 </a:solidFill>
               </a:rPr>
-              <a:t>    18.6 mV  ✓  &lt; 20 mV target</a:t>
+              <a:t>    11.9% / 20.8% / 25.5%  — OCV-limited</a:t>
             </a:r>
           </a:p>
           <a:p>
@@ -5067,7 +5067,7 @@
                   <a:srgbClr val="1A2E5A"/>
                 </a:solidFill>
               </a:rPr>
-              <a:t>  R²  (634 450 real datapoints):</a:t>
+              <a:t>  Current-bias Δ at +2%:</a:t>
             </a:r>
           </a:p>
           <a:p>
@@ -5082,7 +5082,7 @@
                   <a:srgbClr val="1E7A3E"/>
                 </a:solidFill>
               </a:rPr>
-              <a:t>    0.981</a:t>
+              <a:t>    ≤ 0.1 pp  (EKF)  vs  0.7 pp  (PyBaMM)</a:t>
             </a:r>
           </a:p>
           <a:p>
@@ -5127,7 +5127,7 @@
                   <a:srgbClr val="1A2E5A"/>
                 </a:solidFill>
               </a:rPr>
-              <a:t>  Current-bias Δ at +2%:</a:t>
+              <a:t>  Bias-immune via:</a:t>
             </a:r>
           </a:p>
           <a:p>
@@ -5142,7 +5142,7 @@
                   <a:srgbClr val="1E7A3E"/>
                 </a:solidFill>
               </a:rPr>
-              <a:t>    ≤ 0.1 pp  (EKF)  vs  0.7 pp  (PyBaMM)</a:t>
+              <a:t>    V_meas closed-loop Kalman update</a:t>
             </a:r>
           </a:p>
         </p:txBody>

</xml_diff>